<commit_message>
Added Basic Flow Comments / Explanations for each of the project files
</commit_message>
<xml_diff>
--- a/Docs/PD - Final - PPT.pptx
+++ b/Docs/PD - Final - PPT.pptx
@@ -111,6 +111,11 @@
       </a:defRPr>
     </a:lvl9pPr>
   </p:defaultTextStyle>
+  <p:extLst>
+    <p:ext uri="{EFAFB233-063F-42B5-8137-9DF3F51BA10A}">
+      <p15:sldGuideLst xmlns:p15="http://schemas.microsoft.com/office/powerpoint/2012/main"/>
+    </p:ext>
+  </p:extLst>
 </p:presentation>
 </file>
 
@@ -9266,7 +9271,7 @@
           <a:p>
             <a:fld id="{B2D34B87-BA34-4607-A720-BE5C456498A2}" type="datetimeFigureOut">
               <a:rPr lang="es-AR" smtClean="0"/>
-              <a:t>15/11/2025</a:t>
+              <a:t>27/11/2025</a:t>
             </a:fld>
             <a:endParaRPr lang="es-AR" dirty="0"/>
           </a:p>
@@ -9436,7 +9441,7 @@
           <a:p>
             <a:fld id="{B2D34B87-BA34-4607-A720-BE5C456498A2}" type="datetimeFigureOut">
               <a:rPr lang="es-AR" smtClean="0"/>
-              <a:t>15/11/2025</a:t>
+              <a:t>27/11/2025</a:t>
             </a:fld>
             <a:endParaRPr lang="es-AR" dirty="0"/>
           </a:p>
@@ -9616,7 +9621,7 @@
           <a:p>
             <a:fld id="{B2D34B87-BA34-4607-A720-BE5C456498A2}" type="datetimeFigureOut">
               <a:rPr lang="es-AR" smtClean="0"/>
-              <a:t>15/11/2025</a:t>
+              <a:t>27/11/2025</a:t>
             </a:fld>
             <a:endParaRPr lang="es-AR" dirty="0"/>
           </a:p>
@@ -9786,7 +9791,7 @@
           <a:p>
             <a:fld id="{B2D34B87-BA34-4607-A720-BE5C456498A2}" type="datetimeFigureOut">
               <a:rPr lang="es-AR" smtClean="0"/>
-              <a:t>15/11/2025</a:t>
+              <a:t>27/11/2025</a:t>
             </a:fld>
             <a:endParaRPr lang="es-AR" dirty="0"/>
           </a:p>
@@ -10032,7 +10037,7 @@
           <a:p>
             <a:fld id="{B2D34B87-BA34-4607-A720-BE5C456498A2}" type="datetimeFigureOut">
               <a:rPr lang="es-AR" smtClean="0"/>
-              <a:t>15/11/2025</a:t>
+              <a:t>27/11/2025</a:t>
             </a:fld>
             <a:endParaRPr lang="es-AR" dirty="0"/>
           </a:p>
@@ -10264,7 +10269,7 @@
           <a:p>
             <a:fld id="{B2D34B87-BA34-4607-A720-BE5C456498A2}" type="datetimeFigureOut">
               <a:rPr lang="es-AR" smtClean="0"/>
-              <a:t>15/11/2025</a:t>
+              <a:t>27/11/2025</a:t>
             </a:fld>
             <a:endParaRPr lang="es-AR" dirty="0"/>
           </a:p>
@@ -10631,7 +10636,7 @@
           <a:p>
             <a:fld id="{B2D34B87-BA34-4607-A720-BE5C456498A2}" type="datetimeFigureOut">
               <a:rPr lang="es-AR" smtClean="0"/>
-              <a:t>15/11/2025</a:t>
+              <a:t>27/11/2025</a:t>
             </a:fld>
             <a:endParaRPr lang="es-AR" dirty="0"/>
           </a:p>
@@ -10749,7 +10754,7 @@
           <a:p>
             <a:fld id="{B2D34B87-BA34-4607-A720-BE5C456498A2}" type="datetimeFigureOut">
               <a:rPr lang="es-AR" smtClean="0"/>
-              <a:t>15/11/2025</a:t>
+              <a:t>27/11/2025</a:t>
             </a:fld>
             <a:endParaRPr lang="es-AR" dirty="0"/>
           </a:p>
@@ -10844,7 +10849,7 @@
           <a:p>
             <a:fld id="{B2D34B87-BA34-4607-A720-BE5C456498A2}" type="datetimeFigureOut">
               <a:rPr lang="es-AR" smtClean="0"/>
-              <a:t>15/11/2025</a:t>
+              <a:t>27/11/2025</a:t>
             </a:fld>
             <a:endParaRPr lang="es-AR" dirty="0"/>
           </a:p>
@@ -11121,7 +11126,7 @@
           <a:p>
             <a:fld id="{B2D34B87-BA34-4607-A720-BE5C456498A2}" type="datetimeFigureOut">
               <a:rPr lang="es-AR" smtClean="0"/>
-              <a:t>15/11/2025</a:t>
+              <a:t>27/11/2025</a:t>
             </a:fld>
             <a:endParaRPr lang="es-AR" dirty="0"/>
           </a:p>
@@ -11378,7 +11383,7 @@
           <a:p>
             <a:fld id="{B2D34B87-BA34-4607-A720-BE5C456498A2}" type="datetimeFigureOut">
               <a:rPr lang="es-AR" smtClean="0"/>
-              <a:t>15/11/2025</a:t>
+              <a:t>27/11/2025</a:t>
             </a:fld>
             <a:endParaRPr lang="es-AR" dirty="0"/>
           </a:p>
@@ -11591,7 +11596,7 @@
           <a:p>
             <a:fld id="{B2D34B87-BA34-4607-A720-BE5C456498A2}" type="datetimeFigureOut">
               <a:rPr lang="es-AR" smtClean="0"/>
-              <a:t>15/11/2025</a:t>
+              <a:t>27/11/2025</a:t>
             </a:fld>
             <a:endParaRPr lang="es-AR" dirty="0"/>
           </a:p>
@@ -12020,22 +12025,22 @@
         </p:nvPicPr>
         <p:blipFill>
           <a:blip r:embed="rId2">
-            <a:alphaModFix/>
+            <a:alphaModFix amt="40000"/>
             <a:extLst>
               <a:ext uri="{28A0092B-C50C-407E-A947-70E740481C1C}">
                 <a14:useLocalDpi xmlns:a14="http://schemas.microsoft.com/office/drawing/2010/main" val="0"/>
               </a:ext>
             </a:extLst>
           </a:blip>
-          <a:srcRect t="8715" r="-1" b="-1"/>
+          <a:srcRect t="32677" b="8113"/>
           <a:stretch>
             <a:fillRect/>
           </a:stretch>
         </p:blipFill>
         <p:spPr bwMode="auto">
           <a:xfrm>
-            <a:off x="4283902" y="10"/>
-            <a:ext cx="7908098" cy="6857992"/>
+            <a:off x="20" y="10"/>
+            <a:ext cx="12191980" cy="6857990"/>
           </a:xfrm>
           <a:prstGeom prst="rect">
             <a:avLst/>
@@ -12070,8 +12075,8 @@
         </p:nvSpPr>
         <p:spPr>
           <a:xfrm>
-            <a:off x="728663" y="1115219"/>
-            <a:ext cx="7734401" cy="2387600"/>
+            <a:off x="965200" y="965200"/>
+            <a:ext cx="10261600" cy="3564869"/>
           </a:xfrm>
         </p:spPr>
         <p:txBody>
@@ -12082,20 +12087,25 @@
           <a:p>
             <a:pPr algn="l"/>
             <a:r>
-              <a:rPr lang="es-AR" sz="5400" dirty="0">
+              <a:rPr lang="es-AR" sz="11500">
                 <a:ln w="22225">
                   <a:solidFill>
-                    <a:srgbClr val="FFFFFF"/>
+                    <a:schemeClr val="tx1"/>
                   </a:solidFill>
+                  <a:miter lim="800000"/>
                 </a:ln>
                 <a:noFill/>
               </a:rPr>
               <a:t>SOCIAL TREND ANALYZER</a:t>
             </a:r>
-            <a:endParaRPr lang="es-AR" sz="5000" b="1" dirty="0">
-              <a:solidFill>
-                <a:schemeClr val="bg1"/>
-              </a:solidFill>
+            <a:endParaRPr lang="es-AR" sz="11500" b="1">
+              <a:ln w="22225">
+                <a:solidFill>
+                  <a:schemeClr val="tx1"/>
+                </a:solidFill>
+                <a:miter lim="800000"/>
+              </a:ln>
+              <a:noFill/>
             </a:endParaRPr>
           </a:p>
         </p:txBody>
@@ -12118,8 +12128,8 @@
         </p:nvSpPr>
         <p:spPr>
           <a:xfrm>
-            <a:off x="728663" y="3902075"/>
-            <a:ext cx="5505449" cy="1655762"/>
+            <a:off x="965200" y="4572002"/>
+            <a:ext cx="10261600" cy="1202995"/>
           </a:xfrm>
         </p:spPr>
         <p:txBody>
@@ -12130,33 +12140,21 @@
           <a:p>
             <a:pPr algn="l"/>
             <a:r>
-              <a:rPr lang="es-AR" sz="2000" b="1" dirty="0">
-                <a:solidFill>
-                  <a:schemeClr val="bg1"/>
-                </a:solidFill>
-              </a:rPr>
+              <a:rPr lang="es-AR" sz="2000" b="1" dirty="0"/>
               <a:t>UNIVERSIDAD BLAS PASCAL</a:t>
             </a:r>
           </a:p>
           <a:p>
             <a:pPr algn="l"/>
             <a:r>
-              <a:rPr lang="es-AR" sz="2000" b="1" dirty="0">
-                <a:solidFill>
-                  <a:schemeClr val="bg1"/>
-                </a:solidFill>
-              </a:rPr>
+              <a:rPr lang="es-AR" sz="2000" b="1" dirty="0"/>
               <a:t>PROGRAMACIÓN DECLARATIVA - 2025</a:t>
             </a:r>
           </a:p>
           <a:p>
             <a:pPr algn="l"/>
             <a:r>
-              <a:rPr lang="es-AR" sz="2000" b="1" dirty="0">
-                <a:solidFill>
-                  <a:schemeClr val="bg1"/>
-                </a:solidFill>
-              </a:rPr>
+              <a:rPr lang="es-AR" sz="2000" b="1" dirty="0"/>
               <a:t>TOMAS MOLINA Y EDGAR KARPOWICZ</a:t>
             </a:r>
           </a:p>

</xml_diff>